<commit_message>
site: 'Analyse your data' — the live engine, driven from the browser
An eighth dashboard view that uploads a real file to the Railway engine and
renders what comes back: which of your columns were understood and by which
method, how many vendor records were actually one counterparty, every finding
with the exact fields its rule compared, and the deduplicated savings.

The offline guarantee is preserved and was verified, not assumed: a plain page
load still makes zero external requests. The health probe fires only when the
tab is opened, and nothing else on the site can be affected by the engine being
unreachable — the panel says so itself when it is.

Also corrected the deck's slide 05 claim. 'No network calls at runtime' was true
of the whole site until this panel existed; it is now true of the demo, and the
slide distinguishes the two rather than overstating.

Co-Authored-By: Claude Opus 5 <noreply@anthropic.com>
</commit_message>
<xml_diff>
--- a/deck/LedgerLens_Deck.pptx
+++ b/deck/LedgerLens_Deck.pptx
@@ -17065,7 +17065,7 @@
                 </a:solidFill>
                 <a:latin typeface="Segoe UI"/>
               </a:rPr>
-              <a:t>Runs fully offline. </a:t>
+              <a:t>The demo runs fully offline. </a:t>
             </a:r>
             <a:r>
               <a:rPr sz="1000" b="0">
@@ -17074,7 +17074,7 @@
                 </a:solidFill>
                 <a:latin typeface="Segoe UI"/>
               </a:rPr>
-              <a:t>No backend, no network calls at runtime, seeded generation — the demo is byte-identical on every reload and cannot fail on venue wifi.</a:t>
+              <a:t>Bundled client-side, seeded, byte-identical on every reload — it cannot fail on venue wifi. The engine is live; only the ‘analyse your own data’ panel calls it.</a:t>
             </a:r>
           </a:p>
         </p:txBody>

</xml_diff>

<commit_message>
public submission: front-door README, and every figure synced to one measurement
The repo is public now, so it needs to read as the front door rather than a file
listing: what it does, the live links, the reproduce command, the scale table,
the two design decisions worth reading, and an honest statement of what is not
finished.

Also synced site, deck and README to a single measurement. They had drifted to
90.2/98.7/94.3 after the generator changes; the engine currently measures
89.7/98.7/94.0 with TP 148 / FP 17 / FN 2 / TN 1419. A submission whose repo
disagrees with its deck is exactly the failure this project argues against.

Added ROC-AUC 0.960 and PR-AUC 0.899 against a 0.118 baseline to the README —
PR-AUC is the honest one to quote at 11.8% positives, and its baseline is
printed beside it.

Stated weakness moves to Behavioural at 87.0%.

Co-Authored-By: Claude Opus 5 <noreply@anthropic.com>
</commit_message>
<xml_diff>
--- a/deck/LedgerLens_Deck.pptx
+++ b/deck/LedgerLens_Deck.pptx
@@ -3929,7 +3929,7 @@
                 </a:solidFill>
                 <a:latin typeface="Consolas"/>
               </a:rPr>
-              <a:t>90.2%</a:t>
+              <a:t>89.7%</a:t>
             </a:r>
           </a:p>
         </p:txBody>
@@ -18511,7 +18511,7 @@
                 </a:solidFill>
                 <a:latin typeface="Segoe UI"/>
               </a:rPr>
-              <a:t>90.2% precision / 98.7% recall against 150 planted frauds — measured, not asserted</a:t>
+              <a:t>89.7% precision / 98.7% recall against 150 planted frauds — measured, not asserted</a:t>
             </a:r>
           </a:p>
         </p:txBody>
@@ -21860,7 +21860,7 @@
                 </a:solidFill>
                 <a:latin typeface="Consolas"/>
               </a:rPr>
-              <a:t>90.2%</a:t>
+              <a:t>89.7%</a:t>
             </a:r>
           </a:p>
         </p:txBody>
@@ -22116,7 +22116,7 @@
                 </a:solidFill>
                 <a:latin typeface="Consolas"/>
               </a:rPr>
-              <a:t>94.3%</a:t>
+              <a:t>94.0%</a:t>
             </a:r>
           </a:p>
         </p:txBody>
@@ -22200,7 +22200,7 @@
                 </a:solidFill>
                 <a:latin typeface="Consolas"/>
               </a:rPr>
-              <a:t>TP 148 · FP 16 · FN 2 · TN 1,405</a:t>
+              <a:t>TP 148 · FP 17 · FN 2 · TN 1,419</a:t>
             </a:r>
             <a:br/>
             <a:r>
@@ -23064,7 +23064,7 @@
                 </a:solidFill>
                 <a:latin typeface="Consolas"/>
               </a:rPr>
-              <a:t>90.2% / 98.7%</a:t>
+              <a:t>89.7% / 98.7%</a:t>
             </a:r>
           </a:p>
         </p:txBody>

</xml_diff>